<commit_message>
Refresh Figure 5 architecture export from updated PowerPoint slide.
Co-authored-by: Cursor <cursoragent@cursor.com>
</commit_message>
<xml_diff>
--- a/paper_figures/deepsequence.pptx
+++ b/paper_figures/deepsequence.pptx
@@ -5,11 +5,12 @@
     <p:sldMasterId id="2147483648" r:id="rId1"/>
   </p:sldMasterIdLst>
   <p:sldIdLst>
-    <p:sldId id="256" r:id="rId7"/>
-    <p:sldId id="257" r:id="rId8"/>
-    <p:sldId id="258" r:id="rId9"/>
+    <p:sldId id="256" r:id="rId2"/>
+    <p:sldId id="257" r:id="rId3"/>
+    <p:sldId id="258" r:id="rId4"/>
+    <p:sldId id="259" r:id="rId5"/>
   </p:sldIdLst>
-  <p:sldSz cx="12192000" cy="6858000" type="screen4x3"/>
+  <p:sldSz cx="12192000" cy="6858000"/>
   <p:notesSz cx="6858000" cy="9144000"/>
   <p:defaultTextStyle>
     <a:defPPr>
@@ -106,6 +107,22 @@
       </a:defRPr>
     </a:lvl9pPr>
   </p:defaultTextStyle>
+  <p:extLst>
+    <p:ext uri="{EFAFB233-063F-42B5-8137-9DF3F51BA10A}">
+      <p15:sldGuideLst xmlns:p15="http://schemas.microsoft.com/office/powerpoint/2012/main">
+        <p15:guide id="1" orient="horz" pos="2160">
+          <p15:clr>
+            <a:srgbClr val="A4A3A4"/>
+          </p15:clr>
+        </p15:guide>
+        <p15:guide id="2" pos="2880">
+          <p15:clr>
+            <a:srgbClr val="A4A3A4"/>
+          </p15:clr>
+        </p15:guide>
+      </p15:sldGuideLst>
+    </p:ext>
+  </p:extLst>
 </p:presentation>
 </file>
 
@@ -147,10 +164,9 @@
           <a:lstStyle/>
           <a:p>
             <a:r>
-              <a:rPr lang="en-US" smtClean="0"/>
+              <a:rPr lang="en-US"/>
               <a:t>Click to edit Master title style</a:t>
             </a:r>
-            <a:endParaRPr lang="en-US"/>
           </a:p>
         </p:txBody>
       </p:sp>
@@ -266,10 +282,9 @@
           </a:lstStyle>
           <a:p>
             <a:r>
-              <a:rPr lang="en-US" smtClean="0"/>
+              <a:rPr lang="en-US"/>
               <a:t>Click to edit Master subtitle style</a:t>
             </a:r>
-            <a:endParaRPr lang="en-US"/>
           </a:p>
         </p:txBody>
       </p:sp>
@@ -290,7 +305,7 @@
           <a:p>
             <a:fld id="{5BCAD085-E8A6-8845-BD4E-CB4CCA059FC4}" type="datetimeFigureOut">
               <a:rPr lang="en-US" smtClean="0"/>
-              <a:t>1/27/13</a:t>
+              <a:t>8/1/26</a:t>
             </a:fld>
             <a:endParaRPr lang="en-US"/>
           </a:p>
@@ -384,10 +399,9 @@
           <a:lstStyle/>
           <a:p>
             <a:r>
-              <a:rPr lang="en-US" smtClean="0"/>
+              <a:rPr lang="en-US"/>
               <a:t>Click to edit Master title style</a:t>
             </a:r>
-            <a:endParaRPr lang="en-US"/>
           </a:p>
         </p:txBody>
       </p:sp>
@@ -408,38 +422,37 @@
           <a:p>
             <a:pPr lvl="0"/>
             <a:r>
-              <a:rPr lang="en-US" smtClean="0"/>
+              <a:rPr lang="en-US"/>
               <a:t>Click to edit Master text styles</a:t>
             </a:r>
           </a:p>
           <a:p>
             <a:pPr lvl="1"/>
             <a:r>
-              <a:rPr lang="en-US" smtClean="0"/>
+              <a:rPr lang="en-US"/>
               <a:t>Second level</a:t>
             </a:r>
           </a:p>
           <a:p>
             <a:pPr lvl="2"/>
             <a:r>
-              <a:rPr lang="en-US" smtClean="0"/>
+              <a:rPr lang="en-US"/>
               <a:t>Third level</a:t>
             </a:r>
           </a:p>
           <a:p>
             <a:pPr lvl="3"/>
             <a:r>
-              <a:rPr lang="en-US" smtClean="0"/>
+              <a:rPr lang="en-US"/>
               <a:t>Fourth level</a:t>
             </a:r>
           </a:p>
           <a:p>
             <a:pPr lvl="4"/>
             <a:r>
-              <a:rPr lang="en-US" smtClean="0"/>
+              <a:rPr lang="en-US"/>
               <a:t>Fifth level</a:t>
             </a:r>
-            <a:endParaRPr lang="en-US"/>
           </a:p>
         </p:txBody>
       </p:sp>
@@ -460,7 +473,7 @@
           <a:p>
             <a:fld id="{5BCAD085-E8A6-8845-BD4E-CB4CCA059FC4}" type="datetimeFigureOut">
               <a:rPr lang="en-US" smtClean="0"/>
-              <a:t>1/27/13</a:t>
+              <a:t>8/1/26</a:t>
             </a:fld>
             <a:endParaRPr lang="en-US"/>
           </a:p>
@@ -559,10 +572,9 @@
           <a:lstStyle/>
           <a:p>
             <a:r>
-              <a:rPr lang="en-US" smtClean="0"/>
+              <a:rPr lang="en-US"/>
               <a:t>Click to edit Master title style</a:t>
             </a:r>
-            <a:endParaRPr lang="en-US"/>
           </a:p>
         </p:txBody>
       </p:sp>
@@ -588,38 +600,37 @@
           <a:p>
             <a:pPr lvl="0"/>
             <a:r>
-              <a:rPr lang="en-US" smtClean="0"/>
+              <a:rPr lang="en-US"/>
               <a:t>Click to edit Master text styles</a:t>
             </a:r>
           </a:p>
           <a:p>
             <a:pPr lvl="1"/>
             <a:r>
-              <a:rPr lang="en-US" smtClean="0"/>
+              <a:rPr lang="en-US"/>
               <a:t>Second level</a:t>
             </a:r>
           </a:p>
           <a:p>
             <a:pPr lvl="2"/>
             <a:r>
-              <a:rPr lang="en-US" smtClean="0"/>
+              <a:rPr lang="en-US"/>
               <a:t>Third level</a:t>
             </a:r>
           </a:p>
           <a:p>
             <a:pPr lvl="3"/>
             <a:r>
-              <a:rPr lang="en-US" smtClean="0"/>
+              <a:rPr lang="en-US"/>
               <a:t>Fourth level</a:t>
             </a:r>
           </a:p>
           <a:p>
             <a:pPr lvl="4"/>
             <a:r>
-              <a:rPr lang="en-US" smtClean="0"/>
+              <a:rPr lang="en-US"/>
               <a:t>Fifth level</a:t>
             </a:r>
-            <a:endParaRPr lang="en-US"/>
           </a:p>
         </p:txBody>
       </p:sp>
@@ -640,7 +651,7 @@
           <a:p>
             <a:fld id="{5BCAD085-E8A6-8845-BD4E-CB4CCA059FC4}" type="datetimeFigureOut">
               <a:rPr lang="en-US" smtClean="0"/>
-              <a:t>1/27/13</a:t>
+              <a:t>8/1/26</a:t>
             </a:fld>
             <a:endParaRPr lang="en-US"/>
           </a:p>
@@ -734,10 +745,9 @@
           <a:lstStyle/>
           <a:p>
             <a:r>
-              <a:rPr lang="en-US" smtClean="0"/>
+              <a:rPr lang="en-US"/>
               <a:t>Click to edit Master title style</a:t>
             </a:r>
-            <a:endParaRPr lang="en-US"/>
           </a:p>
         </p:txBody>
       </p:sp>
@@ -758,38 +768,37 @@
           <a:p>
             <a:pPr lvl="0"/>
             <a:r>
-              <a:rPr lang="en-US" smtClean="0"/>
+              <a:rPr lang="en-US"/>
               <a:t>Click to edit Master text styles</a:t>
             </a:r>
           </a:p>
           <a:p>
             <a:pPr lvl="1"/>
             <a:r>
-              <a:rPr lang="en-US" smtClean="0"/>
+              <a:rPr lang="en-US"/>
               <a:t>Second level</a:t>
             </a:r>
           </a:p>
           <a:p>
             <a:pPr lvl="2"/>
             <a:r>
-              <a:rPr lang="en-US" smtClean="0"/>
+              <a:rPr lang="en-US"/>
               <a:t>Third level</a:t>
             </a:r>
           </a:p>
           <a:p>
             <a:pPr lvl="3"/>
             <a:r>
-              <a:rPr lang="en-US" smtClean="0"/>
+              <a:rPr lang="en-US"/>
               <a:t>Fourth level</a:t>
             </a:r>
           </a:p>
           <a:p>
             <a:pPr lvl="4"/>
             <a:r>
-              <a:rPr lang="en-US" smtClean="0"/>
+              <a:rPr lang="en-US"/>
               <a:t>Fifth level</a:t>
             </a:r>
-            <a:endParaRPr lang="en-US"/>
           </a:p>
         </p:txBody>
       </p:sp>
@@ -810,7 +819,7 @@
           <a:p>
             <a:fld id="{5BCAD085-E8A6-8845-BD4E-CB4CCA059FC4}" type="datetimeFigureOut">
               <a:rPr lang="en-US" smtClean="0"/>
-              <a:t>1/27/13</a:t>
+              <a:t>8/1/26</a:t>
             </a:fld>
             <a:endParaRPr lang="en-US"/>
           </a:p>
@@ -913,10 +922,9 @@
           </a:lstStyle>
           <a:p>
             <a:r>
-              <a:rPr lang="en-US" smtClean="0"/>
+              <a:rPr lang="en-US"/>
               <a:t>Click to edit Master title style</a:t>
             </a:r>
-            <a:endParaRPr lang="en-US"/>
           </a:p>
         </p:txBody>
       </p:sp>
@@ -1033,7 +1041,7 @@
           <a:p>
             <a:pPr lvl="0"/>
             <a:r>
-              <a:rPr lang="en-US" smtClean="0"/>
+              <a:rPr lang="en-US"/>
               <a:t>Click to edit Master text styles</a:t>
             </a:r>
           </a:p>
@@ -1056,7 +1064,7 @@
           <a:p>
             <a:fld id="{5BCAD085-E8A6-8845-BD4E-CB4CCA059FC4}" type="datetimeFigureOut">
               <a:rPr lang="en-US" smtClean="0"/>
-              <a:t>1/27/13</a:t>
+              <a:t>8/1/26</a:t>
             </a:fld>
             <a:endParaRPr lang="en-US"/>
           </a:p>
@@ -1150,10 +1158,9 @@
           <a:lstStyle/>
           <a:p>
             <a:r>
-              <a:rPr lang="en-US" smtClean="0"/>
+              <a:rPr lang="en-US"/>
               <a:t>Click to edit Master title style</a:t>
             </a:r>
-            <a:endParaRPr lang="en-US"/>
           </a:p>
         </p:txBody>
       </p:sp>
@@ -1207,38 +1214,37 @@
           <a:p>
             <a:pPr lvl="0"/>
             <a:r>
-              <a:rPr lang="en-US" smtClean="0"/>
+              <a:rPr lang="en-US"/>
               <a:t>Click to edit Master text styles</a:t>
             </a:r>
           </a:p>
           <a:p>
             <a:pPr lvl="1"/>
             <a:r>
-              <a:rPr lang="en-US" smtClean="0"/>
+              <a:rPr lang="en-US"/>
               <a:t>Second level</a:t>
             </a:r>
           </a:p>
           <a:p>
             <a:pPr lvl="2"/>
             <a:r>
-              <a:rPr lang="en-US" smtClean="0"/>
+              <a:rPr lang="en-US"/>
               <a:t>Third level</a:t>
             </a:r>
           </a:p>
           <a:p>
             <a:pPr lvl="3"/>
             <a:r>
-              <a:rPr lang="en-US" smtClean="0"/>
+              <a:rPr lang="en-US"/>
               <a:t>Fourth level</a:t>
             </a:r>
           </a:p>
           <a:p>
             <a:pPr lvl="4"/>
             <a:r>
-              <a:rPr lang="en-US" smtClean="0"/>
+              <a:rPr lang="en-US"/>
               <a:t>Fifth level</a:t>
             </a:r>
-            <a:endParaRPr lang="en-US"/>
           </a:p>
         </p:txBody>
       </p:sp>
@@ -1292,38 +1298,37 @@
           <a:p>
             <a:pPr lvl="0"/>
             <a:r>
-              <a:rPr lang="en-US" smtClean="0"/>
+              <a:rPr lang="en-US"/>
               <a:t>Click to edit Master text styles</a:t>
             </a:r>
           </a:p>
           <a:p>
             <a:pPr lvl="1"/>
             <a:r>
-              <a:rPr lang="en-US" smtClean="0"/>
+              <a:rPr lang="en-US"/>
               <a:t>Second level</a:t>
             </a:r>
           </a:p>
           <a:p>
             <a:pPr lvl="2"/>
             <a:r>
-              <a:rPr lang="en-US" smtClean="0"/>
+              <a:rPr lang="en-US"/>
               <a:t>Third level</a:t>
             </a:r>
           </a:p>
           <a:p>
             <a:pPr lvl="3"/>
             <a:r>
-              <a:rPr lang="en-US" smtClean="0"/>
+              <a:rPr lang="en-US"/>
               <a:t>Fourth level</a:t>
             </a:r>
           </a:p>
           <a:p>
             <a:pPr lvl="4"/>
             <a:r>
-              <a:rPr lang="en-US" smtClean="0"/>
+              <a:rPr lang="en-US"/>
               <a:t>Fifth level</a:t>
             </a:r>
-            <a:endParaRPr lang="en-US"/>
           </a:p>
         </p:txBody>
       </p:sp>
@@ -1344,7 +1349,7 @@
           <a:p>
             <a:fld id="{5BCAD085-E8A6-8845-BD4E-CB4CCA059FC4}" type="datetimeFigureOut">
               <a:rPr lang="en-US" smtClean="0"/>
-              <a:t>1/27/13</a:t>
+              <a:t>8/1/26</a:t>
             </a:fld>
             <a:endParaRPr lang="en-US"/>
           </a:p>
@@ -1442,10 +1447,9 @@
           </a:lstStyle>
           <a:p>
             <a:r>
-              <a:rPr lang="en-US" smtClean="0"/>
+              <a:rPr lang="en-US"/>
               <a:t>Click to edit Master title style</a:t>
             </a:r>
-            <a:endParaRPr lang="en-US"/>
           </a:p>
         </p:txBody>
       </p:sp>
@@ -1508,7 +1512,7 @@
           <a:p>
             <a:pPr lvl="0"/>
             <a:r>
-              <a:rPr lang="en-US" smtClean="0"/>
+              <a:rPr lang="en-US"/>
               <a:t>Click to edit Master text styles</a:t>
             </a:r>
           </a:p>
@@ -1564,38 +1568,37 @@
           <a:p>
             <a:pPr lvl="0"/>
             <a:r>
-              <a:rPr lang="en-US" smtClean="0"/>
+              <a:rPr lang="en-US"/>
               <a:t>Click to edit Master text styles</a:t>
             </a:r>
           </a:p>
           <a:p>
             <a:pPr lvl="1"/>
             <a:r>
-              <a:rPr lang="en-US" smtClean="0"/>
+              <a:rPr lang="en-US"/>
               <a:t>Second level</a:t>
             </a:r>
           </a:p>
           <a:p>
             <a:pPr lvl="2"/>
             <a:r>
-              <a:rPr lang="en-US" smtClean="0"/>
+              <a:rPr lang="en-US"/>
               <a:t>Third level</a:t>
             </a:r>
           </a:p>
           <a:p>
             <a:pPr lvl="3"/>
             <a:r>
-              <a:rPr lang="en-US" smtClean="0"/>
+              <a:rPr lang="en-US"/>
               <a:t>Fourth level</a:t>
             </a:r>
           </a:p>
           <a:p>
             <a:pPr lvl="4"/>
             <a:r>
-              <a:rPr lang="en-US" smtClean="0"/>
+              <a:rPr lang="en-US"/>
               <a:t>Fifth level</a:t>
             </a:r>
-            <a:endParaRPr lang="en-US"/>
           </a:p>
         </p:txBody>
       </p:sp>
@@ -1658,7 +1661,7 @@
           <a:p>
             <a:pPr lvl="0"/>
             <a:r>
-              <a:rPr lang="en-US" smtClean="0"/>
+              <a:rPr lang="en-US"/>
               <a:t>Click to edit Master text styles</a:t>
             </a:r>
           </a:p>
@@ -1714,38 +1717,37 @@
           <a:p>
             <a:pPr lvl="0"/>
             <a:r>
-              <a:rPr lang="en-US" smtClean="0"/>
+              <a:rPr lang="en-US"/>
               <a:t>Click to edit Master text styles</a:t>
             </a:r>
           </a:p>
           <a:p>
             <a:pPr lvl="1"/>
             <a:r>
-              <a:rPr lang="en-US" smtClean="0"/>
+              <a:rPr lang="en-US"/>
               <a:t>Second level</a:t>
             </a:r>
           </a:p>
           <a:p>
             <a:pPr lvl="2"/>
             <a:r>
-              <a:rPr lang="en-US" smtClean="0"/>
+              <a:rPr lang="en-US"/>
               <a:t>Third level</a:t>
             </a:r>
           </a:p>
           <a:p>
             <a:pPr lvl="3"/>
             <a:r>
-              <a:rPr lang="en-US" smtClean="0"/>
+              <a:rPr lang="en-US"/>
               <a:t>Fourth level</a:t>
             </a:r>
           </a:p>
           <a:p>
             <a:pPr lvl="4"/>
             <a:r>
-              <a:rPr lang="en-US" smtClean="0"/>
+              <a:rPr lang="en-US"/>
               <a:t>Fifth level</a:t>
             </a:r>
-            <a:endParaRPr lang="en-US"/>
           </a:p>
         </p:txBody>
       </p:sp>
@@ -1766,7 +1768,7 @@
           <a:p>
             <a:fld id="{5BCAD085-E8A6-8845-BD4E-CB4CCA059FC4}" type="datetimeFigureOut">
               <a:rPr lang="en-US" smtClean="0"/>
-              <a:t>1/27/13</a:t>
+              <a:t>8/1/26</a:t>
             </a:fld>
             <a:endParaRPr lang="en-US"/>
           </a:p>
@@ -1860,10 +1862,9 @@
           <a:lstStyle/>
           <a:p>
             <a:r>
-              <a:rPr lang="en-US" smtClean="0"/>
+              <a:rPr lang="en-US"/>
               <a:t>Click to edit Master title style</a:t>
             </a:r>
-            <a:endParaRPr lang="en-US"/>
           </a:p>
         </p:txBody>
       </p:sp>
@@ -1884,7 +1885,7 @@
           <a:p>
             <a:fld id="{5BCAD085-E8A6-8845-BD4E-CB4CCA059FC4}" type="datetimeFigureOut">
               <a:rPr lang="en-US" smtClean="0"/>
-              <a:t>1/27/13</a:t>
+              <a:t>8/1/26</a:t>
             </a:fld>
             <a:endParaRPr lang="en-US"/>
           </a:p>
@@ -1979,7 +1980,7 @@
           <a:p>
             <a:fld id="{5BCAD085-E8A6-8845-BD4E-CB4CCA059FC4}" type="datetimeFigureOut">
               <a:rPr lang="en-US" smtClean="0"/>
-              <a:t>1/27/13</a:t>
+              <a:t>8/1/26</a:t>
             </a:fld>
             <a:endParaRPr lang="en-US"/>
           </a:p>
@@ -2082,10 +2083,9 @@
           </a:lstStyle>
           <a:p>
             <a:r>
-              <a:rPr lang="en-US" smtClean="0"/>
+              <a:rPr lang="en-US"/>
               <a:t>Click to edit Master title style</a:t>
             </a:r>
-            <a:endParaRPr lang="en-US"/>
           </a:p>
         </p:txBody>
       </p:sp>
@@ -2139,38 +2139,37 @@
           <a:p>
             <a:pPr lvl="0"/>
             <a:r>
-              <a:rPr lang="en-US" smtClean="0"/>
+              <a:rPr lang="en-US"/>
               <a:t>Click to edit Master text styles</a:t>
             </a:r>
           </a:p>
           <a:p>
             <a:pPr lvl="1"/>
             <a:r>
-              <a:rPr lang="en-US" smtClean="0"/>
+              <a:rPr lang="en-US"/>
               <a:t>Second level</a:t>
             </a:r>
           </a:p>
           <a:p>
             <a:pPr lvl="2"/>
             <a:r>
-              <a:rPr lang="en-US" smtClean="0"/>
+              <a:rPr lang="en-US"/>
               <a:t>Third level</a:t>
             </a:r>
           </a:p>
           <a:p>
             <a:pPr lvl="3"/>
             <a:r>
-              <a:rPr lang="en-US" smtClean="0"/>
+              <a:rPr lang="en-US"/>
               <a:t>Fourth level</a:t>
             </a:r>
           </a:p>
           <a:p>
             <a:pPr lvl="4"/>
             <a:r>
-              <a:rPr lang="en-US" smtClean="0"/>
+              <a:rPr lang="en-US"/>
               <a:t>Fifth level</a:t>
             </a:r>
-            <a:endParaRPr lang="en-US"/>
           </a:p>
         </p:txBody>
       </p:sp>
@@ -2233,7 +2232,7 @@
           <a:p>
             <a:pPr lvl="0"/>
             <a:r>
-              <a:rPr lang="en-US" smtClean="0"/>
+              <a:rPr lang="en-US"/>
               <a:t>Click to edit Master text styles</a:t>
             </a:r>
           </a:p>
@@ -2256,7 +2255,7 @@
           <a:p>
             <a:fld id="{5BCAD085-E8A6-8845-BD4E-CB4CCA059FC4}" type="datetimeFigureOut">
               <a:rPr lang="en-US" smtClean="0"/>
-              <a:t>1/27/13</a:t>
+              <a:t>8/1/26</a:t>
             </a:fld>
             <a:endParaRPr lang="en-US"/>
           </a:p>
@@ -2359,10 +2358,9 @@
           </a:lstStyle>
           <a:p>
             <a:r>
-              <a:rPr lang="en-US" smtClean="0"/>
+              <a:rPr lang="en-US"/>
               <a:t>Click to edit Master title style</a:t>
             </a:r>
-            <a:endParaRPr lang="en-US"/>
           </a:p>
         </p:txBody>
       </p:sp>
@@ -2486,7 +2484,7 @@
           <a:p>
             <a:pPr lvl="0"/>
             <a:r>
-              <a:rPr lang="en-US" smtClean="0"/>
+              <a:rPr lang="en-US"/>
               <a:t>Click to edit Master text styles</a:t>
             </a:r>
           </a:p>
@@ -2509,7 +2507,7 @@
           <a:p>
             <a:fld id="{5BCAD085-E8A6-8845-BD4E-CB4CCA059FC4}" type="datetimeFigureOut">
               <a:rPr lang="en-US" smtClean="0"/>
-              <a:t>1/27/13</a:t>
+              <a:t>8/1/26</a:t>
             </a:fld>
             <a:endParaRPr lang="en-US"/>
           </a:p>
@@ -2618,10 +2616,9 @@
           <a:lstStyle/>
           <a:p>
             <a:r>
-              <a:rPr lang="en-US" smtClean="0"/>
+              <a:rPr lang="en-US"/>
               <a:t>Click to edit Master title style</a:t>
             </a:r>
-            <a:endParaRPr lang="en-US"/>
           </a:p>
         </p:txBody>
       </p:sp>
@@ -2652,38 +2649,37 @@
           <a:p>
             <a:pPr lvl="0"/>
             <a:r>
-              <a:rPr lang="en-US" smtClean="0"/>
+              <a:rPr lang="en-US"/>
               <a:t>Click to edit Master text styles</a:t>
             </a:r>
           </a:p>
           <a:p>
             <a:pPr lvl="1"/>
             <a:r>
-              <a:rPr lang="en-US" smtClean="0"/>
+              <a:rPr lang="en-US"/>
               <a:t>Second level</a:t>
             </a:r>
           </a:p>
           <a:p>
             <a:pPr lvl="2"/>
             <a:r>
-              <a:rPr lang="en-US" smtClean="0"/>
+              <a:rPr lang="en-US"/>
               <a:t>Third level</a:t>
             </a:r>
           </a:p>
           <a:p>
             <a:pPr lvl="3"/>
             <a:r>
-              <a:rPr lang="en-US" smtClean="0"/>
+              <a:rPr lang="en-US"/>
               <a:t>Fourth level</a:t>
             </a:r>
           </a:p>
           <a:p>
             <a:pPr lvl="4"/>
             <a:r>
-              <a:rPr lang="en-US" smtClean="0"/>
+              <a:rPr lang="en-US"/>
               <a:t>Fifth level</a:t>
             </a:r>
-            <a:endParaRPr lang="en-US"/>
           </a:p>
         </p:txBody>
       </p:sp>
@@ -2722,7 +2718,7 @@
           <a:p>
             <a:fld id="{5BCAD085-E8A6-8845-BD4E-CB4CCA059FC4}" type="datetimeFigureOut">
               <a:rPr lang="en-US" smtClean="0"/>
-              <a:t>1/27/13</a:t>
+              <a:t>8/1/26</a:t>
             </a:fld>
             <a:endParaRPr lang="en-US"/>
           </a:p>
@@ -3081,7 +3077,7 @@
 </file>
 
 <file path=ppt/slides/slide1.xml><?xml version="1.0" encoding="utf-8"?>
-<p:sld xmlns:a="http://schemas.openxmlformats.org/drawingml/2006/main" xmlns:p="http://schemas.openxmlformats.org/presentationml/2006/main" xmlns:r="http://schemas.openxmlformats.org/officeDocument/2006/relationships">
+<p:sld xmlns:a="http://schemas.openxmlformats.org/drawingml/2006/main" xmlns:r="http://schemas.openxmlformats.org/officeDocument/2006/relationships" xmlns:p="http://schemas.openxmlformats.org/presentationml/2006/main">
   <p:cSld>
     <p:spTree>
       <p:nvGrpSpPr>
@@ -3089,7 +3085,14 @@
         <p:cNvGrpSpPr/>
         <p:nvPr/>
       </p:nvGrpSpPr>
-      <p:grpSpPr/>
+      <p:grpSpPr>
+        <a:xfrm>
+          <a:off x="0" y="0"/>
+          <a:ext cx="0" cy="0"/>
+          <a:chOff x="0" y="0"/>
+          <a:chExt cx="0" cy="0"/>
+        </a:xfrm>
+      </p:grpSpPr>
       <p:pic>
         <p:nvPicPr>
           <p:cNvPr id="2" name="Picture 1" descr="fig_changepoint_monotone.png"/>
@@ -3123,7 +3126,7 @@
 </file>
 
 <file path=ppt/slides/slide2.xml><?xml version="1.0" encoding="utf-8"?>
-<p:sld xmlns:a="http://schemas.openxmlformats.org/drawingml/2006/main" xmlns:p="http://schemas.openxmlformats.org/presentationml/2006/main" xmlns:r="http://schemas.openxmlformats.org/officeDocument/2006/relationships">
+<p:sld xmlns:a="http://schemas.openxmlformats.org/drawingml/2006/main" xmlns:r="http://schemas.openxmlformats.org/officeDocument/2006/relationships" xmlns:p="http://schemas.openxmlformats.org/presentationml/2006/main">
   <p:cSld>
     <p:spTree>
       <p:nvGrpSpPr>
@@ -3131,7 +3134,14 @@
         <p:cNvGrpSpPr/>
         <p:nvPr/>
       </p:nvGrpSpPr>
-      <p:grpSpPr/>
+      <p:grpSpPr>
+        <a:xfrm>
+          <a:off x="0" y="0"/>
+          <a:ext cx="0" cy="0"/>
+          <a:chOff x="0" y="0"/>
+          <a:chExt cx="0" cy="0"/>
+        </a:xfrm>
+      </p:grpSpPr>
       <p:pic>
         <p:nvPicPr>
           <p:cNvPr id="2" name="Picture 1" descr="fig_hierarchical_attention_internals.png"/>
@@ -3165,7 +3175,7 @@
 </file>
 
 <file path=ppt/slides/slide3.xml><?xml version="1.0" encoding="utf-8"?>
-<p:sld xmlns:a="http://schemas.openxmlformats.org/drawingml/2006/main" xmlns:p="http://schemas.openxmlformats.org/presentationml/2006/main" xmlns:r="http://schemas.openxmlformats.org/officeDocument/2006/relationships">
+<p:sld xmlns:a="http://schemas.openxmlformats.org/drawingml/2006/main" xmlns:r="http://schemas.openxmlformats.org/officeDocument/2006/relationships" xmlns:p="http://schemas.openxmlformats.org/presentationml/2006/main">
   <p:cSld>
     <p:spTree>
       <p:nvGrpSpPr>
@@ -3173,10 +3183,23 @@
         <p:cNvGrpSpPr/>
         <p:nvPr/>
       </p:nvGrpSpPr>
-      <p:grpSpPr/>
+      <p:grpSpPr>
+        <a:xfrm>
+          <a:off x="0" y="0"/>
+          <a:ext cx="0" cy="0"/>
+          <a:chOff x="0" y="0"/>
+          <a:chExt cx="0" cy="0"/>
+        </a:xfrm>
+      </p:grpSpPr>
       <p:pic>
         <p:nvPicPr>
-          <p:cNvPr id="2" name="Picture 1" descr="deepsequence_shared_from_ppt_adjusted_v4.png"/>
+          <p:cNvPr id="2" name="Picture 1">
+            <a:extLst>
+              <a:ext uri="{FF2B5EF4-FFF2-40B4-BE49-F238E27FC236}">
+                <a16:creationId xmlns:a16="http://schemas.microsoft.com/office/drawing/2014/main" id="{1F4D6E10-68F3-9AEC-6D11-15E432ED7BAC}"/>
+              </a:ext>
+            </a:extLst>
+          </p:cNvPr>
           <p:cNvPicPr>
             <a:picLocks noChangeAspect="1"/>
           </p:cNvPicPr>
@@ -3190,8 +3213,8 @@
         </p:blipFill>
         <p:spPr>
           <a:xfrm>
-            <a:off x="1158240" y="137160"/>
-            <a:ext cx="9875520" cy="6583680"/>
+            <a:off x="1219200" y="177800"/>
+            <a:ext cx="9753600" cy="6502400"/>
           </a:xfrm>
           <a:prstGeom prst="rect">
             <a:avLst/>
@@ -3199,6 +3222,36 @@
         </p:spPr>
       </p:pic>
     </p:spTree>
+  </p:cSld>
+  <p:clrMapOvr>
+    <a:masterClrMapping/>
+  </p:clrMapOvr>
+</p:sld>
+</file>
+
+<file path=ppt/slides/slide4.xml><?xml version="1.0" encoding="utf-8"?>
+<p:sld xmlns:a="http://schemas.openxmlformats.org/drawingml/2006/main" xmlns:r="http://schemas.openxmlformats.org/officeDocument/2006/relationships" xmlns:p="http://schemas.openxmlformats.org/presentationml/2006/main">
+  <p:cSld>
+    <p:spTree>
+      <p:nvGrpSpPr>
+        <p:cNvPr id="1" name=""/>
+        <p:cNvGrpSpPr/>
+        <p:nvPr/>
+      </p:nvGrpSpPr>
+      <p:grpSpPr>
+        <a:xfrm>
+          <a:off x="0" y="0"/>
+          <a:ext cx="0" cy="0"/>
+          <a:chOff x="0" y="0"/>
+          <a:chExt cx="0" cy="0"/>
+        </a:xfrm>
+      </p:grpSpPr>
+    </p:spTree>
+    <p:extLst>
+      <p:ext uri="{BB962C8B-B14F-4D97-AF65-F5344CB8AC3E}">
+        <p14:creationId xmlns:p14="http://schemas.microsoft.com/office/powerpoint/2010/main" val="2534426216"/>
+      </p:ext>
+    </p:extLst>
   </p:cSld>
   <p:clrMapOvr>
     <a:masterClrMapping/>

</xml_diff>